<commit_message>
Identify 0.45 MeV contaminant as a low-energy proton background
Kinematic fingerprint (fingerprint_contaminant.C, 47 runs / 56k events):
back-angle contaminant protons sit at E_ej~2.5 MeV vs ~5.4 MeV for genuine
transfer at the same angles (and ~2.5 MeV forward too) -- inconsistent with
a low-Ex 17C level, which would give MORE energetic protons. Vertex shifted
~9 cm downstream. => low-energy proton background, not a 17C state.
Adds contam_vs_angle (87% of yield at theta_cm>=30) + fingerprint figures
and a deck backup slide; updates TODO item 4.

Co-Authored-By: Claude Opus 4.8 (1M context) <noreply@anthropic.com>
</commit_message>
<xml_diff>
--- a/Presentations/C17_analysis_overview.pptx
+++ b/Presentations/C17_analysis_overview.pptx
@@ -23,6 +23,7 @@
     <p:sldId id="271" r:id="rId22"/>
     <p:sldId id="272" r:id="rId23"/>
     <p:sldId id="273" r:id="rId24"/>
+    <p:sldId id="274" r:id="rId25"/>
   </p:sldIdLst>
   <p:sldSz cx="12191695" cy="6858000" type="screen4x3"/>
   <p:notesSz cx="6858000" cy="9144000"/>
@@ -6597,6 +6598,349 @@
                 </a:solidFill>
               </a:rPr>
               <a:t>•  Also in the 82-variant envelope; L-scan uses θ ≤ 30°. Back-angle limit is stats/efficiency, not bg.</a:t>
+            </a:r>
+          </a:p>
+        </p:txBody>
+      </p:sp>
+    </p:spTree>
+  </p:cSld>
+  <p:clrMapOvr>
+    <a:masterClrMapping/>
+  </p:clrMapOvr>
+</p:sld>
+</file>
+
+<file path=ppt/slides/slide19.xml><?xml version="1.0" encoding="utf-8"?>
+<p:sld xmlns:a="http://schemas.openxmlformats.org/drawingml/2006/main" xmlns:p="http://schemas.openxmlformats.org/presentationml/2006/main" xmlns:r="http://schemas.openxmlformats.org/officeDocument/2006/relationships">
+  <p:cSld>
+    <p:spTree>
+      <p:nvGrpSpPr>
+        <p:cNvPr id="1" name=""/>
+        <p:cNvGrpSpPr/>
+        <p:nvPr/>
+      </p:nvGrpSpPr>
+      <p:grpSpPr/>
+      <p:sp>
+        <p:nvSpPr>
+          <p:cNvPr id="2" name="Rectangle 1"/>
+          <p:cNvSpPr/>
+          <p:nvPr/>
+        </p:nvSpPr>
+        <p:spPr>
+          <a:xfrm>
+            <a:off x="0" y="0"/>
+            <a:ext cx="12191695" cy="868680"/>
+          </a:xfrm>
+          <a:prstGeom prst="rect">
+            <a:avLst/>
+          </a:prstGeom>
+          <a:solidFill>
+            <a:srgbClr val="6F1D46"/>
+          </a:solidFill>
+          <a:ln>
+            <a:noFill/>
+          </a:ln>
+          <a:effectLst/>
+        </p:spPr>
+        <p:style>
+          <a:lnRef idx="1">
+            <a:schemeClr val="accent1"/>
+          </a:lnRef>
+          <a:fillRef idx="3">
+            <a:schemeClr val="accent1"/>
+          </a:fillRef>
+          <a:effectRef idx="2">
+            <a:schemeClr val="accent1"/>
+          </a:effectRef>
+          <a:fontRef idx="minor">
+            <a:schemeClr val="lt1"/>
+          </a:fontRef>
+        </p:style>
+        <p:txBody>
+          <a:bodyPr rtlCol="0" anchor="ctr"/>
+          <a:lstStyle/>
+          <a:p>
+            <a:pPr algn="ctr"/>
+          </a:p>
+        </p:txBody>
+      </p:sp>
+      <p:sp>
+        <p:nvSpPr>
+          <p:cNvPr id="3" name="Rectangle 2"/>
+          <p:cNvSpPr/>
+          <p:nvPr/>
+        </p:nvSpPr>
+        <p:spPr>
+          <a:xfrm>
+            <a:off x="0" y="868680"/>
+            <a:ext cx="12191695" cy="45720"/>
+          </a:xfrm>
+          <a:prstGeom prst="rect">
+            <a:avLst/>
+          </a:prstGeom>
+          <a:solidFill>
+            <a:srgbClr val="B3477D"/>
+          </a:solidFill>
+          <a:ln>
+            <a:noFill/>
+          </a:ln>
+          <a:effectLst/>
+        </p:spPr>
+        <p:style>
+          <a:lnRef idx="1">
+            <a:schemeClr val="accent1"/>
+          </a:lnRef>
+          <a:fillRef idx="3">
+            <a:schemeClr val="accent1"/>
+          </a:fillRef>
+          <a:effectRef idx="2">
+            <a:schemeClr val="accent1"/>
+          </a:effectRef>
+          <a:fontRef idx="minor">
+            <a:schemeClr val="lt1"/>
+          </a:fontRef>
+        </p:style>
+        <p:txBody>
+          <a:bodyPr rtlCol="0" anchor="ctr"/>
+          <a:lstStyle/>
+          <a:p>
+            <a:pPr algn="ctr"/>
+          </a:p>
+        </p:txBody>
+      </p:sp>
+      <p:sp>
+        <p:nvSpPr>
+          <p:cNvPr id="4" name="TextBox 3"/>
+          <p:cNvSpPr txBox="1"/>
+          <p:nvPr/>
+        </p:nvSpPr>
+        <p:spPr>
+          <a:xfrm>
+            <a:off x="274320" y="118872"/>
+            <a:ext cx="8961120" cy="640080"/>
+          </a:xfrm>
+          <a:prstGeom prst="rect">
+            <a:avLst/>
+          </a:prstGeom>
+          <a:noFill/>
+        </p:spPr>
+        <p:txBody>
+          <a:bodyPr wrap="none">
+            <a:spAutoFit/>
+          </a:bodyPr>
+          <a:lstStyle/>
+          <a:p>
+            <a:r>
+              <a:rPr sz="2700" b="1">
+                <a:solidFill>
+                  <a:srgbClr val="FFFFFF"/>
+                </a:solidFill>
+              </a:rPr>
+              <a:t>Backup: the 0.45 MeV contaminant is a low-energy proton background</a:t>
+            </a:r>
+          </a:p>
+        </p:txBody>
+      </p:sp>
+      <p:sp>
+        <p:nvSpPr>
+          <p:cNvPr id="5" name="TextBox 4"/>
+          <p:cNvSpPr txBox="1"/>
+          <p:nvPr/>
+        </p:nvSpPr>
+        <p:spPr>
+          <a:xfrm>
+            <a:off x="8778240" y="256032"/>
+            <a:ext cx="3108960" cy="457200"/>
+          </a:xfrm>
+          <a:prstGeom prst="rect">
+            <a:avLst/>
+          </a:prstGeom>
+          <a:noFill/>
+        </p:spPr>
+        <p:txBody>
+          <a:bodyPr wrap="none">
+            <a:spAutoFit/>
+          </a:bodyPr>
+          <a:lstStyle/>
+          <a:p>
+            <a:pPr algn="r"/>
+            <a:r>
+              <a:rPr sz="1300" i="1">
+                <a:solidFill>
+                  <a:srgbClr val="FFFFFF"/>
+                </a:solidFill>
+              </a:rPr>
+              <a:t>contaminant</a:t>
+            </a:r>
+          </a:p>
+        </p:txBody>
+      </p:sp>
+      <p:sp>
+        <p:nvSpPr>
+          <p:cNvPr id="6" name="TextBox 5"/>
+          <p:cNvSpPr txBox="1"/>
+          <p:nvPr/>
+        </p:nvSpPr>
+        <p:spPr>
+          <a:xfrm>
+            <a:off x="274320" y="6446520"/>
+            <a:ext cx="8686800" cy="320040"/>
+          </a:xfrm>
+          <a:prstGeom prst="rect">
+            <a:avLst/>
+          </a:prstGeom>
+          <a:noFill/>
+        </p:spPr>
+        <p:txBody>
+          <a:bodyPr wrap="none">
+            <a:spAutoFit/>
+          </a:bodyPr>
+          <a:lstStyle/>
+          <a:p>
+            <a:r>
+              <a:rPr sz="900">
+                <a:solidFill>
+                  <a:srgbClr val="555555"/>
+                </a:solidFill>
+              </a:rPr>
+              <a:t>¹⁶C(d,p)¹⁷C  ·  FRIB a1975  ·  Y. Ayyad (USC)</a:t>
+            </a:r>
+          </a:p>
+        </p:txBody>
+      </p:sp>
+      <p:pic>
+        <p:nvPicPr>
+          <p:cNvPr id="7" name="Picture 6" descr="contam_fingerprint.png"/>
+          <p:cNvPicPr>
+            <a:picLocks noChangeAspect="1"/>
+          </p:cNvPicPr>
+          <p:nvPr/>
+        </p:nvPicPr>
+        <p:blipFill>
+          <a:blip r:embed="rId2"/>
+          <a:stretch>
+            <a:fillRect/>
+          </a:stretch>
+        </p:blipFill>
+        <p:spPr>
+          <a:xfrm>
+            <a:off x="137160" y="1114700"/>
+            <a:ext cx="7955279" cy="4902919"/>
+          </a:xfrm>
+          <a:prstGeom prst="rect">
+            <a:avLst/>
+          </a:prstGeom>
+        </p:spPr>
+      </p:pic>
+      <p:sp>
+        <p:nvSpPr>
+          <p:cNvPr id="8" name="TextBox 7"/>
+          <p:cNvSpPr txBox="1"/>
+          <p:nvPr/>
+        </p:nvSpPr>
+        <p:spPr>
+          <a:xfrm>
+            <a:off x="8229600" y="1143000"/>
+            <a:ext cx="3840480" cy="5029200"/>
+          </a:xfrm>
+          <a:prstGeom prst="rect">
+            <a:avLst/>
+          </a:prstGeom>
+          <a:noFill/>
+        </p:spPr>
+        <p:txBody>
+          <a:bodyPr wrap="square">
+            <a:spAutoFit/>
+          </a:bodyPr>
+          <a:lstStyle/>
+          <a:p>
+            <a:pPr algn="l">
+              <a:spcAft>
+                <a:spcPts val="600"/>
+              </a:spcAft>
+            </a:pPr>
+            <a:r>
+              <a:rPr sz="1200" b="0" i="0">
+                <a:solidFill>
+                  <a:srgbClr val="1A1A1A"/>
+                </a:solidFill>
+              </a:rPr>
+              <a:t>•  Back-angle feature: ~87% of its fitted yield at θ_cm ≥ 30° (contam_vs_angle).</a:t>
+            </a:r>
+          </a:p>
+          <a:p>
+            <a:pPr algn="l">
+              <a:spcAft>
+                <a:spcPts val="600"/>
+              </a:spcAft>
+            </a:pPr>
+            <a:r>
+              <a:rPr sz="1200" b="0" i="0">
+                <a:solidFill>
+                  <a:srgbClr val="1A1A1A"/>
+                </a:solidFill>
+              </a:rPr>
+              <a:t>•  Fingerprint (47 runs, 56k events): contaminant protons have E_ej ≈ 2.5 MeV vs ~5.4 MeV for genuine transfer at the same back angles.</a:t>
+            </a:r>
+          </a:p>
+          <a:p>
+            <a:pPr algn="l">
+              <a:spcAft>
+                <a:spcPts val="600"/>
+              </a:spcAft>
+            </a:pPr>
+            <a:r>
+              <a:rPr sz="1200" b="0" i="0">
+                <a:solidFill>
+                  <a:srgbClr val="1A1A1A"/>
+                </a:solidFill>
+              </a:rPr>
+              <a:t>•  Same ~2.5 MeV forward too — a fixed low-energy population.</a:t>
+            </a:r>
+          </a:p>
+          <a:p>
+            <a:pPr algn="l">
+              <a:spcAft>
+                <a:spcPts val="600"/>
+              </a:spcAft>
+            </a:pPr>
+            <a:r>
+              <a:rPr sz="1200" b="0" i="0">
+                <a:solidFill>
+                  <a:srgbClr val="1A1A1A"/>
+                </a:solidFill>
+              </a:rPr>
+              <a:t>•  A real 0.45 MeV ¹⁷C state would give MORE energetic protons than the Eₓ≈4 reference, not half ⇒ these don't obey ¹⁶C(d,p) kinematics.</a:t>
+            </a:r>
+          </a:p>
+          <a:p>
+            <a:pPr algn="l">
+              <a:spcAft>
+                <a:spcPts val="600"/>
+              </a:spcAft>
+            </a:pPr>
+            <a:r>
+              <a:rPr sz="1200" b="0" i="0">
+                <a:solidFill>
+                  <a:srgbClr val="1A1A1A"/>
+                </a:solidFill>
+              </a:rPr>
+              <a:t>•  Vertex ~9 cm downstream (62.7 vs 53.4 cm).</a:t>
+            </a:r>
+          </a:p>
+          <a:p>
+            <a:pPr algn="l">
+              <a:spcAft>
+                <a:spcPts val="600"/>
+              </a:spcAft>
+            </a:pPr>
+            <a:r>
+              <a:rPr sz="1200" b="0" i="0">
+                <a:solidFill>
+                  <a:srgbClr val="1A1A1A"/>
+                </a:solidFill>
+              </a:rPr>
+              <a:t>•  ⇒ low-energy proton background, NOT a ¹⁷C level; a back-angle E_ej / vertex cut would remove it.</a:t>
             </a:r>
           </a:p>
         </p:txBody>

</xml_diff>

<commit_message>
Correct contaminant fingerprint: inconclusive, not a background ID
Retract the previous commit's conclusion. Those E_ej numbers (2.5 vs 5.4
MeV) came from a corrupted terminal read; the real figure shows the opposite
ordering. More importantly the E_ej test is CIRCULAR (Ex is reconstructed
from E_ej and theta), so it cannot separate signal from background. The
Ex-independent vertex_z shows no clear anomaly. Fingerprint is inconclusive;
the 0.45 MeV excess is NOT identified as background. Proper test needs
Ex-independent discriminants (redchisq, spatial clustering, Ex(theta) ridge).

Co-Authored-By: Claude Opus 4.8 (1M context) <noreply@anthropic.com>
</commit_message>
<xml_diff>
--- a/Presentations/C17_analysis_overview.pptx
+++ b/Presentations/C17_analysis_overview.pptx
@@ -6736,7 +6736,7 @@
                   <a:srgbClr val="FFFFFF"/>
                 </a:solidFill>
               </a:rPr>
-              <a:t>Backup: the 0.45 MeV contaminant is a low-energy proton background</a:t>
+              <a:t>Backup: 0.45 MeV contaminant - kinematic fingerprint (inconclusive)</a:t>
             </a:r>
           </a:p>
         </p:txBody>
@@ -6880,7 +6880,7 @@
                   <a:srgbClr val="1A1A1A"/>
                 </a:solidFill>
               </a:rPr>
-              <a:t>•  Fingerprint (47 runs, 56k events): contaminant protons have E_ej ≈ 2.5 MeV vs ~5.4 MeV for genuine transfer at the same back angles.</a:t>
+              <a:t>•  Caveat: the E_ej comparison is CIRCULAR — Eₓ is built from E_ej and θ, so the 0.45-MeV window's protons must follow low-Eₓ kinematics; it cannot separate signal from background.</a:t>
             </a:r>
           </a:p>
           <a:p>
@@ -6895,7 +6895,7 @@
                   <a:srgbClr val="1A1A1A"/>
                 </a:solidFill>
               </a:rPr>
-              <a:t>•  Same ~2.5 MeV forward too — a fixed low-energy population.</a:t>
+              <a:t>•  Eₓ-independent vertex_z: the back-angle contaminant looks like genuine transfer — no clear anomaly.</a:t>
             </a:r>
           </a:p>
           <a:p>
@@ -6910,7 +6910,7 @@
                   <a:srgbClr val="1A1A1A"/>
                 </a:solidFill>
               </a:rPr>
-              <a:t>•  A real 0.45 MeV ¹⁷C state would give MORE energetic protons than the Eₓ≈4 reference, not half ⇒ these don't obey ¹⁶C(d,p) kinematics.</a:t>
+              <a:t>•  ⇒ this simple test does NOT flag it as background; its nature is still open.</a:t>
             </a:r>
           </a:p>
           <a:p>
@@ -6925,22 +6925,7 @@
                   <a:srgbClr val="1A1A1A"/>
                 </a:solidFill>
               </a:rPr>
-              <a:t>•  Vertex ~9 cm downstream (62.7 vs 53.4 cm).</a:t>
-            </a:r>
-          </a:p>
-          <a:p>
-            <a:pPr algn="l">
-              <a:spcAft>
-                <a:spcPts val="600"/>
-              </a:spcAft>
-            </a:pPr>
-            <a:r>
-              <a:rPr sz="1200" b="0" i="0">
-                <a:solidFill>
-                  <a:srgbClr val="1A1A1A"/>
-                </a:solidFill>
-              </a:rPr>
-              <a:t>•  ⇒ low-energy proton background, NOT a ¹⁷C level; a back-angle E_ej / vertex cut would remove it.</a:t>
+              <a:t>•  Next: Eₓ-independent discriminants — track redchisq, spatial clustering, slanted Eₓ(θ) ridge vs vertical band.</a:t>
             </a:r>
           </a:p>
         </p:txBody>

</xml_diff>

<commit_message>
Fix PLB 811 comparison: use correct CM-frame data
The previous plb_overlay figure came from overlay_paper_data.py, which
HAND-DIGITIZED the paper and applied a homemade lab->CM Jacobian -- this was
the 'wrong data'. Replaced with overlay_both_data_calcs.png (overlay_both.py),
which loads the correct dp_AngularDistro_*_CM.dat files directly (proper CM
frame, both beam energies, no extra normalization).

Also: verified the bound-state absolute scale uses the SAME beam x target
luminosity constant (pi/pt = kNbeam/kNtarget) validated against the 16C(d,d)
elastic channel (om_elastic.py, data/OM ~0.86-0.98, ~12% OMP-spread). Report
text + captions updated accordingly. Added the two PLB slides to make_pptx.py
(PPTX was missing them); both decks now 21 slides.

Co-Authored-By: Claude Opus 4.8 (1M context) <noreply@anthropic.com>
</commit_message>
<xml_diff>
--- a/Presentations/C17_analysis_overview.pptx
+++ b/Presentations/C17_analysis_overview.pptx
@@ -24,6 +24,8 @@
     <p:sldId id="272" r:id="rId23"/>
     <p:sldId id="273" r:id="rId24"/>
     <p:sldId id="274" r:id="rId25"/>
+    <p:sldId id="275" r:id="rId26"/>
+    <p:sldId id="276" r:id="rId27"/>
   </p:sldIdLst>
   <p:sldSz cx="12191695" cy="6858000" type="screen4x3"/>
   <p:notesSz cx="6858000" cy="9144000"/>
@@ -7450,6 +7452,790 @@
                 <a:latin typeface="Courier New"/>
               </a:rPr>
               <a:t>6.30     5/2+     396</a:t>
+            </a:r>
+          </a:p>
+        </p:txBody>
+      </p:sp>
+    </p:spTree>
+  </p:cSld>
+  <p:clrMapOvr>
+    <a:masterClrMapping/>
+  </p:clrMapOvr>
+</p:sld>
+</file>
+
+<file path=ppt/slides/slide20.xml><?xml version="1.0" encoding="utf-8"?>
+<p:sld xmlns:a="http://schemas.openxmlformats.org/drawingml/2006/main" xmlns:p="http://schemas.openxmlformats.org/presentationml/2006/main" xmlns:r="http://schemas.openxmlformats.org/officeDocument/2006/relationships">
+  <p:cSld>
+    <p:spTree>
+      <p:nvGrpSpPr>
+        <p:cNvPr id="1" name=""/>
+        <p:cNvGrpSpPr/>
+        <p:nvPr/>
+      </p:nvGrpSpPr>
+      <p:grpSpPr/>
+      <p:sp>
+        <p:nvSpPr>
+          <p:cNvPr id="2" name="Rectangle 1"/>
+          <p:cNvSpPr/>
+          <p:nvPr/>
+        </p:nvSpPr>
+        <p:spPr>
+          <a:xfrm>
+            <a:off x="0" y="0"/>
+            <a:ext cx="12191695" cy="868680"/>
+          </a:xfrm>
+          <a:prstGeom prst="rect">
+            <a:avLst/>
+          </a:prstGeom>
+          <a:solidFill>
+            <a:srgbClr val="6F1D46"/>
+          </a:solidFill>
+          <a:ln>
+            <a:noFill/>
+          </a:ln>
+          <a:effectLst/>
+        </p:spPr>
+        <p:style>
+          <a:lnRef idx="1">
+            <a:schemeClr val="accent1"/>
+          </a:lnRef>
+          <a:fillRef idx="3">
+            <a:schemeClr val="accent1"/>
+          </a:fillRef>
+          <a:effectRef idx="2">
+            <a:schemeClr val="accent1"/>
+          </a:effectRef>
+          <a:fontRef idx="minor">
+            <a:schemeClr val="lt1"/>
+          </a:fontRef>
+        </p:style>
+        <p:txBody>
+          <a:bodyPr rtlCol="0" anchor="ctr"/>
+          <a:lstStyle/>
+          <a:p>
+            <a:pPr algn="ctr"/>
+          </a:p>
+        </p:txBody>
+      </p:sp>
+      <p:sp>
+        <p:nvSpPr>
+          <p:cNvPr id="3" name="Rectangle 2"/>
+          <p:cNvSpPr/>
+          <p:nvPr/>
+        </p:nvSpPr>
+        <p:spPr>
+          <a:xfrm>
+            <a:off x="0" y="868680"/>
+            <a:ext cx="12191695" cy="45720"/>
+          </a:xfrm>
+          <a:prstGeom prst="rect">
+            <a:avLst/>
+          </a:prstGeom>
+          <a:solidFill>
+            <a:srgbClr val="B3477D"/>
+          </a:solidFill>
+          <a:ln>
+            <a:noFill/>
+          </a:ln>
+          <a:effectLst/>
+        </p:spPr>
+        <p:style>
+          <a:lnRef idx="1">
+            <a:schemeClr val="accent1"/>
+          </a:lnRef>
+          <a:fillRef idx="3">
+            <a:schemeClr val="accent1"/>
+          </a:fillRef>
+          <a:effectRef idx="2">
+            <a:schemeClr val="accent1"/>
+          </a:effectRef>
+          <a:fontRef idx="minor">
+            <a:schemeClr val="lt1"/>
+          </a:fontRef>
+        </p:style>
+        <p:txBody>
+          <a:bodyPr rtlCol="0" anchor="ctr"/>
+          <a:lstStyle/>
+          <a:p>
+            <a:pPr algn="ctr"/>
+          </a:p>
+        </p:txBody>
+      </p:sp>
+      <p:sp>
+        <p:nvSpPr>
+          <p:cNvPr id="4" name="TextBox 3"/>
+          <p:cNvSpPr txBox="1"/>
+          <p:nvPr/>
+        </p:nvSpPr>
+        <p:spPr>
+          <a:xfrm>
+            <a:off x="274320" y="118872"/>
+            <a:ext cx="8961120" cy="640080"/>
+          </a:xfrm>
+          <a:prstGeom prst="rect">
+            <a:avLst/>
+          </a:prstGeom>
+          <a:noFill/>
+        </p:spPr>
+        <p:txBody>
+          <a:bodyPr wrap="none">
+            <a:spAutoFit/>
+          </a:bodyPr>
+          <a:lstStyle/>
+          <a:p>
+            <a:r>
+              <a:rPr sz="2700" b="1">
+                <a:solidFill>
+                  <a:srgbClr val="FFFFFF"/>
+                </a:solidFill>
+              </a:rPr>
+              <a:t>Comparison with Pereira-Lopez et al. (PLB 811, 135939)</a:t>
+            </a:r>
+          </a:p>
+        </p:txBody>
+      </p:sp>
+      <p:sp>
+        <p:nvSpPr>
+          <p:cNvPr id="5" name="TextBox 4"/>
+          <p:cNvSpPr txBox="1"/>
+          <p:nvPr/>
+        </p:nvSpPr>
+        <p:spPr>
+          <a:xfrm>
+            <a:off x="8778240" y="256032"/>
+            <a:ext cx="3108960" cy="457200"/>
+          </a:xfrm>
+          <a:prstGeom prst="rect">
+            <a:avLst/>
+          </a:prstGeom>
+          <a:noFill/>
+        </p:spPr>
+        <p:txBody>
+          <a:bodyPr wrap="none">
+            <a:spAutoFit/>
+          </a:bodyPr>
+          <a:lstStyle/>
+          <a:p>
+            <a:pPr algn="r"/>
+            <a:r>
+              <a:rPr sz="1300" i="1">
+                <a:solidFill>
+                  <a:srgbClr val="FFFFFF"/>
+                </a:solidFill>
+              </a:rPr>
+              <a:t>bound states</a:t>
+            </a:r>
+          </a:p>
+        </p:txBody>
+      </p:sp>
+      <p:sp>
+        <p:nvSpPr>
+          <p:cNvPr id="6" name="TextBox 5"/>
+          <p:cNvSpPr txBox="1"/>
+          <p:nvPr/>
+        </p:nvSpPr>
+        <p:spPr>
+          <a:xfrm>
+            <a:off x="274320" y="6446520"/>
+            <a:ext cx="8686800" cy="320040"/>
+          </a:xfrm>
+          <a:prstGeom prst="rect">
+            <a:avLst/>
+          </a:prstGeom>
+          <a:noFill/>
+        </p:spPr>
+        <p:txBody>
+          <a:bodyPr wrap="none">
+            <a:spAutoFit/>
+          </a:bodyPr>
+          <a:lstStyle/>
+          <a:p>
+            <a:r>
+              <a:rPr sz="900">
+                <a:solidFill>
+                  <a:srgbClr val="555555"/>
+                </a:solidFill>
+              </a:rPr>
+              <a:t>¹⁶C(d,p)¹⁷C  ·  FRIB a1975  ·  Y. Ayyad (USC)</a:t>
+            </a:r>
+          </a:p>
+        </p:txBody>
+      </p:sp>
+      <p:pic>
+        <p:nvPicPr>
+          <p:cNvPr id="7" name="Picture 6" descr="plb_overlay.png"/>
+          <p:cNvPicPr>
+            <a:picLocks noChangeAspect="1"/>
+          </p:cNvPicPr>
+          <p:nvPr/>
+        </p:nvPicPr>
+        <p:blipFill>
+          <a:blip r:embed="rId2"/>
+          <a:stretch>
+            <a:fillRect/>
+          </a:stretch>
+        </p:blipFill>
+        <p:spPr>
+          <a:xfrm>
+            <a:off x="464458" y="960120"/>
+            <a:ext cx="3825963" cy="5394960"/>
+          </a:xfrm>
+          <a:prstGeom prst="rect">
+            <a:avLst/>
+          </a:prstGeom>
+        </p:spPr>
+      </p:pic>
+      <p:sp>
+        <p:nvSpPr>
+          <p:cNvPr id="8" name="TextBox 7"/>
+          <p:cNvSpPr txBox="1"/>
+          <p:nvPr/>
+        </p:nvSpPr>
+        <p:spPr>
+          <a:xfrm>
+            <a:off x="5029200" y="1051560"/>
+            <a:ext cx="6766560" cy="365760"/>
+          </a:xfrm>
+          <a:prstGeom prst="rect">
+            <a:avLst/>
+          </a:prstGeom>
+          <a:noFill/>
+        </p:spPr>
+        <p:txBody>
+          <a:bodyPr wrap="square">
+            <a:spAutoFit/>
+          </a:bodyPr>
+          <a:lstStyle/>
+          <a:p>
+            <a:pPr algn="l">
+              <a:spcAft>
+                <a:spcPts val="600"/>
+              </a:spcAft>
+            </a:pPr>
+            <a:r>
+              <a:rPr sz="1400" b="1" i="0">
+                <a:solidFill>
+                  <a:srgbClr val="6F1D46"/>
+                </a:solidFill>
+              </a:rPr>
+              <a:t>•  Bound-state C²S: PLB vs this work</a:t>
+            </a:r>
+          </a:p>
+        </p:txBody>
+      </p:sp>
+      <p:sp>
+        <p:nvSpPr>
+          <p:cNvPr id="9" name="TextBox 8"/>
+          <p:cNvSpPr txBox="1"/>
+          <p:nvPr/>
+        </p:nvSpPr>
+        <p:spPr>
+          <a:xfrm>
+            <a:off x="5029200" y="1600200"/>
+            <a:ext cx="6766560" cy="2011680"/>
+          </a:xfrm>
+          <a:prstGeom prst="rect">
+            <a:avLst/>
+          </a:prstGeom>
+          <a:noFill/>
+        </p:spPr>
+        <p:txBody>
+          <a:bodyPr wrap="square">
+            <a:spAutoFit/>
+          </a:bodyPr>
+          <a:lstStyle/>
+          <a:p>
+            <a:pPr algn="l">
+              <a:spcAft>
+                <a:spcPts val="200"/>
+              </a:spcAft>
+            </a:pPr>
+            <a:r>
+              <a:rPr sz="1250" b="0" i="0">
+                <a:solidFill>
+                  <a:srgbClr val="1A1A1A"/>
+                </a:solidFill>
+                <a:latin typeface="Courier New"/>
+              </a:rPr>
+              <a:t>state        l   PLB        this work</a:t>
+            </a:r>
+          </a:p>
+          <a:p>
+            <a:pPr algn="l">
+              <a:spcAft>
+                <a:spcPts val="200"/>
+              </a:spcAft>
+            </a:pPr>
+            <a:r>
+              <a:rPr sz="1250" b="0" i="0">
+                <a:solidFill>
+                  <a:srgbClr val="1A1A1A"/>
+                </a:solidFill>
+                <a:latin typeface="Courier New"/>
+              </a:rPr>
+              <a:t>----------------------------------------</a:t>
+            </a:r>
+          </a:p>
+          <a:p>
+            <a:pPr algn="l">
+              <a:spcAft>
+                <a:spcPts val="200"/>
+              </a:spcAft>
+            </a:pPr>
+            <a:r>
+              <a:rPr sz="1250" b="0" i="0">
+                <a:solidFill>
+                  <a:srgbClr val="1A1A1A"/>
+                </a:solidFill>
+                <a:latin typeface="Courier New"/>
+              </a:rPr>
+              <a:t>gs 3/2+      2   0.03       -&gt; 0</a:t>
+            </a:r>
+          </a:p>
+          <a:p>
+            <a:pPr algn="l">
+              <a:spcAft>
+                <a:spcPts val="200"/>
+              </a:spcAft>
+            </a:pPr>
+            <a:r>
+              <a:rPr sz="1250" b="0" i="0">
+                <a:solidFill>
+                  <a:srgbClr val="1A1A1A"/>
+                </a:solidFill>
+                <a:latin typeface="Courier New"/>
+              </a:rPr>
+              <a:t>0.217 1/2+   0   0.64(18)   0.54(10)</a:t>
+            </a:r>
+          </a:p>
+          <a:p>
+            <a:pPr algn="l">
+              <a:spcAft>
+                <a:spcPts val="200"/>
+              </a:spcAft>
+            </a:pPr>
+            <a:r>
+              <a:rPr sz="1250" b="0" i="0">
+                <a:solidFill>
+                  <a:srgbClr val="1A1A1A"/>
+                </a:solidFill>
+                <a:latin typeface="Courier New"/>
+              </a:rPr>
+              <a:t>0.335 5/2+   2   0.62(13)   0.47-0.74</a:t>
+            </a:r>
+          </a:p>
+        </p:txBody>
+      </p:sp>
+      <p:sp>
+        <p:nvSpPr>
+          <p:cNvPr id="10" name="TextBox 9"/>
+          <p:cNvSpPr txBox="1"/>
+          <p:nvPr/>
+        </p:nvSpPr>
+        <p:spPr>
+          <a:xfrm>
+            <a:off x="5029200" y="3657600"/>
+            <a:ext cx="6766560" cy="2743200"/>
+          </a:xfrm>
+          <a:prstGeom prst="rect">
+            <a:avLst/>
+          </a:prstGeom>
+          <a:noFill/>
+        </p:spPr>
+        <p:txBody>
+          <a:bodyPr wrap="square">
+            <a:spAutoFit/>
+          </a:bodyPr>
+          <a:lstStyle/>
+          <a:p>
+            <a:pPr algn="l">
+              <a:spcAft>
+                <a:spcPts val="600"/>
+              </a:spcAft>
+            </a:pPr>
+            <a:r>
+              <a:rPr sz="1200" b="0" i="0">
+                <a:solidFill>
+                  <a:srgbClr val="1A1A1A"/>
+                </a:solidFill>
+              </a:rPr>
+              <a:t>•  CM-frame angular distributions (both datasets, both FRESCO energies, no extra normalization).</a:t>
+            </a:r>
+          </a:p>
+          <a:p>
+            <a:pPr algn="l">
+              <a:spcAft>
+                <a:spcPts val="600"/>
+              </a:spcAft>
+            </a:pPr>
+            <a:r>
+              <a:rPr sz="1200" b="0" i="0">
+                <a:solidFill>
+                  <a:srgbClr val="1A1A1A"/>
+                </a:solidFill>
+              </a:rPr>
+              <a:t>•  Our absolute scale is validated vs the ¹⁶C(d,d) elastic channel (same beam×target luminosity).</a:t>
+            </a:r>
+          </a:p>
+          <a:p>
+            <a:pPr algn="l">
+              <a:spcAft>
+                <a:spcPts val="600"/>
+              </a:spcAft>
+            </a:pPr>
+            <a:r>
+              <a:rPr sz="1200" b="0" i="0">
+                <a:solidFill>
+                  <a:srgbClr val="1A1A1A"/>
+                </a:solidFill>
+              </a:rPr>
+              <a:t>•  1/2⁺ and 5/2⁺ C²S reproduced within ~1σ; g.s. 3/2⁺ consistent with the small published value.</a:t>
+            </a:r>
+          </a:p>
+          <a:p>
+            <a:pPr algn="l">
+              <a:spcAft>
+                <a:spcPts val="600"/>
+              </a:spcAft>
+            </a:pPr>
+            <a:r>
+              <a:rPr sz="1200" b="0" i="0">
+                <a:solidFill>
+                  <a:srgbClr val="1A1A1A"/>
+                </a:solidFill>
+              </a:rPr>
+              <a:t>•  Companion analysis: repo 16Cdp17C_PLB_comparison.</a:t>
+            </a:r>
+          </a:p>
+        </p:txBody>
+      </p:sp>
+    </p:spTree>
+  </p:cSld>
+  <p:clrMapOvr>
+    <a:masterClrMapping/>
+  </p:clrMapOvr>
+</p:sld>
+</file>
+
+<file path=ppt/slides/slide21.xml><?xml version="1.0" encoding="utf-8"?>
+<p:sld xmlns:a="http://schemas.openxmlformats.org/drawingml/2006/main" xmlns:p="http://schemas.openxmlformats.org/presentationml/2006/main" xmlns:r="http://schemas.openxmlformats.org/officeDocument/2006/relationships">
+  <p:cSld>
+    <p:spTree>
+      <p:nvGrpSpPr>
+        <p:cNvPr id="1" name=""/>
+        <p:cNvGrpSpPr/>
+        <p:nvPr/>
+      </p:nvGrpSpPr>
+      <p:grpSpPr/>
+      <p:sp>
+        <p:nvSpPr>
+          <p:cNvPr id="2" name="Rectangle 1"/>
+          <p:cNvSpPr/>
+          <p:nvPr/>
+        </p:nvSpPr>
+        <p:spPr>
+          <a:xfrm>
+            <a:off x="0" y="0"/>
+            <a:ext cx="12191695" cy="868680"/>
+          </a:xfrm>
+          <a:prstGeom prst="rect">
+            <a:avLst/>
+          </a:prstGeom>
+          <a:solidFill>
+            <a:srgbClr val="6F1D46"/>
+          </a:solidFill>
+          <a:ln>
+            <a:noFill/>
+          </a:ln>
+          <a:effectLst/>
+        </p:spPr>
+        <p:style>
+          <a:lnRef idx="1">
+            <a:schemeClr val="accent1"/>
+          </a:lnRef>
+          <a:fillRef idx="3">
+            <a:schemeClr val="accent1"/>
+          </a:fillRef>
+          <a:effectRef idx="2">
+            <a:schemeClr val="accent1"/>
+          </a:effectRef>
+          <a:fontRef idx="minor">
+            <a:schemeClr val="lt1"/>
+          </a:fontRef>
+        </p:style>
+        <p:txBody>
+          <a:bodyPr rtlCol="0" anchor="ctr"/>
+          <a:lstStyle/>
+          <a:p>
+            <a:pPr algn="ctr"/>
+          </a:p>
+        </p:txBody>
+      </p:sp>
+      <p:sp>
+        <p:nvSpPr>
+          <p:cNvPr id="3" name="Rectangle 2"/>
+          <p:cNvSpPr/>
+          <p:nvPr/>
+        </p:nvSpPr>
+        <p:spPr>
+          <a:xfrm>
+            <a:off x="0" y="868680"/>
+            <a:ext cx="12191695" cy="45720"/>
+          </a:xfrm>
+          <a:prstGeom prst="rect">
+            <a:avLst/>
+          </a:prstGeom>
+          <a:solidFill>
+            <a:srgbClr val="B3477D"/>
+          </a:solidFill>
+          <a:ln>
+            <a:noFill/>
+          </a:ln>
+          <a:effectLst/>
+        </p:spPr>
+        <p:style>
+          <a:lnRef idx="1">
+            <a:schemeClr val="accent1"/>
+          </a:lnRef>
+          <a:fillRef idx="3">
+            <a:schemeClr val="accent1"/>
+          </a:fillRef>
+          <a:effectRef idx="2">
+            <a:schemeClr val="accent1"/>
+          </a:effectRef>
+          <a:fontRef idx="minor">
+            <a:schemeClr val="lt1"/>
+          </a:fontRef>
+        </p:style>
+        <p:txBody>
+          <a:bodyPr rtlCol="0" anchor="ctr"/>
+          <a:lstStyle/>
+          <a:p>
+            <a:pPr algn="ctr"/>
+          </a:p>
+        </p:txBody>
+      </p:sp>
+      <p:sp>
+        <p:nvSpPr>
+          <p:cNvPr id="4" name="TextBox 3"/>
+          <p:cNvSpPr txBox="1"/>
+          <p:nvPr/>
+        </p:nvSpPr>
+        <p:spPr>
+          <a:xfrm>
+            <a:off x="274320" y="118872"/>
+            <a:ext cx="8961120" cy="640080"/>
+          </a:xfrm>
+          <a:prstGeom prst="rect">
+            <a:avLst/>
+          </a:prstGeom>
+          <a:noFill/>
+        </p:spPr>
+        <p:txBody>
+          <a:bodyPr wrap="none">
+            <a:spAutoFit/>
+          </a:bodyPr>
+          <a:lstStyle/>
+          <a:p>
+            <a:r>
+              <a:rPr sz="2700" b="1">
+                <a:solidFill>
+                  <a:srgbClr val="FFFFFF"/>
+                </a:solidFill>
+              </a:rPr>
+              <a:t>PLB 811 comparison: per-state bound-state fits</a:t>
+            </a:r>
+          </a:p>
+        </p:txBody>
+      </p:sp>
+      <p:sp>
+        <p:nvSpPr>
+          <p:cNvPr id="5" name="TextBox 4"/>
+          <p:cNvSpPr txBox="1"/>
+          <p:nvPr/>
+        </p:nvSpPr>
+        <p:spPr>
+          <a:xfrm>
+            <a:off x="8778240" y="256032"/>
+            <a:ext cx="3108960" cy="457200"/>
+          </a:xfrm>
+          <a:prstGeom prst="rect">
+            <a:avLst/>
+          </a:prstGeom>
+          <a:noFill/>
+        </p:spPr>
+        <p:txBody>
+          <a:bodyPr wrap="none">
+            <a:spAutoFit/>
+          </a:bodyPr>
+          <a:lstStyle/>
+          <a:p>
+            <a:pPr algn="r"/>
+            <a:r>
+              <a:rPr sz="1300" i="1">
+                <a:solidFill>
+                  <a:srgbClr val="FFFFFF"/>
+                </a:solidFill>
+              </a:rPr>
+              <a:t>bound states</a:t>
+            </a:r>
+          </a:p>
+        </p:txBody>
+      </p:sp>
+      <p:sp>
+        <p:nvSpPr>
+          <p:cNvPr id="6" name="TextBox 5"/>
+          <p:cNvSpPr txBox="1"/>
+          <p:nvPr/>
+        </p:nvSpPr>
+        <p:spPr>
+          <a:xfrm>
+            <a:off x="274320" y="6446520"/>
+            <a:ext cx="8686800" cy="320040"/>
+          </a:xfrm>
+          <a:prstGeom prst="rect">
+            <a:avLst/>
+          </a:prstGeom>
+          <a:noFill/>
+        </p:spPr>
+        <p:txBody>
+          <a:bodyPr wrap="none">
+            <a:spAutoFit/>
+          </a:bodyPr>
+          <a:lstStyle/>
+          <a:p>
+            <a:r>
+              <a:rPr sz="900">
+                <a:solidFill>
+                  <a:srgbClr val="555555"/>
+                </a:solidFill>
+              </a:rPr>
+              <a:t>¹⁶C(d,p)¹⁷C  ·  FRIB a1975  ·  Y. Ayyad (USC)</a:t>
+            </a:r>
+          </a:p>
+        </p:txBody>
+      </p:sp>
+      <p:pic>
+        <p:nvPicPr>
+          <p:cNvPr id="7" name="Picture 6" descr="plb_cm_panels.png"/>
+          <p:cNvPicPr>
+            <a:picLocks noChangeAspect="1"/>
+          </p:cNvPicPr>
+          <p:nvPr/>
+        </p:nvPicPr>
+        <p:blipFill>
+          <a:blip r:embed="rId2"/>
+          <a:stretch>
+            <a:fillRect/>
+          </a:stretch>
+        </p:blipFill>
+        <p:spPr>
+          <a:xfrm>
+            <a:off x="182880" y="2377631"/>
+            <a:ext cx="7315200" cy="2377056"/>
+          </a:xfrm>
+          <a:prstGeom prst="rect">
+            <a:avLst/>
+          </a:prstGeom>
+        </p:spPr>
+      </p:pic>
+      <p:pic>
+        <p:nvPicPr>
+          <p:cNvPr id="8" name="Picture 7" descr="plb_sfs_overlay.png"/>
+          <p:cNvPicPr>
+            <a:picLocks noChangeAspect="1"/>
+          </p:cNvPicPr>
+          <p:nvPr/>
+        </p:nvPicPr>
+        <p:blipFill>
+          <a:blip r:embed="rId3"/>
+          <a:stretch>
+            <a:fillRect/>
+          </a:stretch>
+        </p:blipFill>
+        <p:spPr>
+          <a:xfrm>
+            <a:off x="7726679" y="1680210"/>
+            <a:ext cx="4297680" cy="3223260"/>
+          </a:xfrm>
+          <a:prstGeom prst="rect">
+            <a:avLst/>
+          </a:prstGeom>
+        </p:spPr>
+      </p:pic>
+      <p:sp>
+        <p:nvSpPr>
+          <p:cNvPr id="9" name="TextBox 8"/>
+          <p:cNvSpPr txBox="1"/>
+          <p:nvPr/>
+        </p:nvSpPr>
+        <p:spPr>
+          <a:xfrm>
+            <a:off x="182880" y="6172200"/>
+            <a:ext cx="7498079" cy="457200"/>
+          </a:xfrm>
+          <a:prstGeom prst="rect">
+            <a:avLst/>
+          </a:prstGeom>
+          <a:noFill/>
+        </p:spPr>
+        <p:txBody>
+          <a:bodyPr wrap="square">
+            <a:spAutoFit/>
+          </a:bodyPr>
+          <a:lstStyle/>
+          <a:p>
+            <a:pPr algn="l">
+              <a:spcAft>
+                <a:spcPts val="600"/>
+              </a:spcAft>
+            </a:pPr>
+            <a:r>
+              <a:rPr sz="1050" b="0" i="0">
+                <a:solidFill>
+                  <a:srgbClr val="555555"/>
+                </a:solidFill>
+              </a:rPr>
+              <a:t>•  Per-state dσ/dΩ vs FRESCO with the published spectroscopic factors  (a: bound-states sum,  b: 0.217 1/2⁺ SF=0.64,  c: 0.335 5/2⁺ SF=0.62).</a:t>
+            </a:r>
+          </a:p>
+        </p:txBody>
+      </p:sp>
+      <p:sp>
+        <p:nvSpPr>
+          <p:cNvPr id="10" name="TextBox 9"/>
+          <p:cNvSpPr txBox="1"/>
+          <p:nvPr/>
+        </p:nvSpPr>
+        <p:spPr>
+          <a:xfrm>
+            <a:off x="7726679" y="5349240"/>
+            <a:ext cx="4297680" cy="731520"/>
+          </a:xfrm>
+          <a:prstGeom prst="rect">
+            <a:avLst/>
+          </a:prstGeom>
+          <a:noFill/>
+        </p:spPr>
+        <p:txBody>
+          <a:bodyPr wrap="square">
+            <a:spAutoFit/>
+          </a:bodyPr>
+          <a:lstStyle/>
+          <a:p>
+            <a:pPr algn="l">
+              <a:spcAft>
+                <a:spcPts val="600"/>
+              </a:spcAft>
+            </a:pPr>
+            <a:r>
+              <a:rPr sz="1050" b="0" i="0">
+                <a:solidFill>
+                  <a:srgbClr val="555555"/>
+                </a:solidFill>
+              </a:rPr>
+              <a:t>•  Right: paper SFs applied to our DWBA, summed vs efficiency-corrected data.</a:t>
             </a:r>
           </a:p>
         </p:txBody>

</xml_diff>